<commit_message>
Refactor project structure and remove obsolete code
</commit_message>
<xml_diff>
--- a/doc/problem-locator-open-source-insight-ppt/OpenSRE-四页介绍.pptx
+++ b/doc/problem-locator-open-source-insight-ppt/OpenSRE-四页介绍.pptx
@@ -1144,7 +1144,7 @@
       </p:grpSpPr>
       <p:pic>
         <p:nvPicPr>
-          <p:cNvPr id="2" name="Image 0" descr="D:\code\xiaodao\.tmp\opensre-ppt-review\slide-05-1920x1080.png">    </p:cNvPr>
+          <p:cNvPr id="2" name="Image 0" descr="D:\code\xiaodao\.tmp\opensre-ppt-review\slide-05-3840x2160.png">    </p:cNvPr>
           <p:cNvPicPr>
             <a:picLocks noChangeAspect="1"/>
           </p:cNvPicPr>
@@ -1200,7 +1200,7 @@
       </p:grpSpPr>
       <p:pic>
         <p:nvPicPr>
-          <p:cNvPr id="2" name="Image 0" descr="D:\code\xiaodao\.tmp\opensre-ppt-review\slide-06-1920x1080.png">    </p:cNvPr>
+          <p:cNvPr id="2" name="Image 0" descr="D:\code\xiaodao\.tmp\opensre-ppt-review\slide-06-3840x2160.png">    </p:cNvPr>
           <p:cNvPicPr>
             <a:picLocks noChangeAspect="1"/>
           </p:cNvPicPr>
@@ -1256,7 +1256,7 @@
       </p:grpSpPr>
       <p:pic>
         <p:nvPicPr>
-          <p:cNvPr id="2" name="Image 0" descr="D:\code\xiaodao\.tmp\opensre-ppt-review\slide-07-1920x1080.png">    </p:cNvPr>
+          <p:cNvPr id="2" name="Image 0" descr="D:\code\xiaodao\.tmp\opensre-ppt-review\slide-07-3840x2160.png">    </p:cNvPr>
           <p:cNvPicPr>
             <a:picLocks noChangeAspect="1"/>
           </p:cNvPicPr>
@@ -1312,7 +1312,7 @@
       </p:grpSpPr>
       <p:pic>
         <p:nvPicPr>
-          <p:cNvPr id="2" name="Image 0" descr="D:\code\xiaodao\.tmp\opensre-ppt-review\slide-08-1920x1080.png">    </p:cNvPr>
+          <p:cNvPr id="2" name="Image 0" descr="D:\code\xiaodao\.tmp\opensre-ppt-review\slide-08-3840x2160.png">    </p:cNvPr>
           <p:cNvPicPr>
             <a:picLocks noChangeAspect="1"/>
           </p:cNvPicPr>

</xml_diff>